<commit_message>
Drag to move across the sand table
Dragging now pans the view over the table instead of only orbiting a
fixed centre: right-drag (or Ctrl / Shift / Cmd + drag on a trackpad)
turns and tilts, the wheel zooms toward the pointer, one finger pans on
touch screens and two fingers zoom and turn. The centre stays over the
table and follows the terrain, and clicking the compass turns the view
back to north. Help text, legend, README and the guide deck describe
the new controls.

Co-Authored-By: Claude Opus 5.5 <noreply@anthropic.com>
Claude-Session: https://claude.ai/code/session_015Zqxwg6mTMYtB1fNrmJkji
</commit_message>
<xml_diff>
--- a/docs/feishui-guide.pptx
+++ b/docs/feishui-guide.pptx
@@ -143,7 +143,7 @@
   <p:extLst>
     <p:ext uri="{521415D9-36F7-43E2-AB2F-B90AF26B5E84}">
       <p14:sectionLst xmlns:p14="http://schemas.microsoft.com/office/powerpoint/2010/main">
-        <p14:section name="开篇" id="{bd70b5a6-29da-d23d-4291-25221c47841f}">
+        <p14:section name="开篇" id="{a199276b-3eb3-79cc-e20d-23ae38b2c2fc}">
           <p14:sldIdLst>
             <p14:sldId id="256"/>
             <p14:sldId id="257"/>
@@ -154,7 +154,7 @@
             <p14:sldId id="262"/>
           </p14:sldIdLst>
         </p14:section>
-        <p14:section name="战略全局（第一至三节）" id="{8b0452db-e8cc-a974-7488-167c8b0c9841}">
+        <p14:section name="战略全局（第一至三节）" id="{b40934d4-d029-dca2-543e-220a37492e2a}">
           <p14:sldIdLst>
             <p14:sldId id="263"/>
             <p14:sldId id="264"/>
@@ -164,7 +164,7 @@
             <p14:sldId id="268"/>
           </p14:sldIdLst>
         </p14:section>
-        <p14:section name="淝水战场（第四至八节）" id="{5a02a728-c1fd-f33b-c907-298a2eb658bc}">
+        <p14:section name="淝水战场（第四至八节）" id="{2f9758fc-9ecb-bb9a-9f82-57398edd4668}">
           <p14:sldIdLst>
             <p14:sldId id="269"/>
             <p14:sldId id="270"/>
@@ -178,7 +178,7 @@
             <p14:sldId id="278"/>
           </p14:sldIdLst>
         </p14:section>
-        <p14:section name="决战与溃败（第九至十一节）" id="{401f240a-fcc0-1f82-1fa2-45ee0172629b}">
+        <p14:section name="决战与溃败（第九至十一节）" id="{5152f7e5-281a-2d98-d79c-8ce06e07f44c}">
           <p14:sldIdLst>
             <p14:sldId id="279"/>
             <p14:sldId id="280"/>
@@ -188,7 +188,7 @@
             <p14:sldId id="284"/>
           </p14:sldIdLst>
         </p14:section>
-        <p14:section name="战后（第十二、十三节）" id="{3c05d02e-fca4-fb92-0ab3-a2305f5544bc}">
+        <p14:section name="战后（第十二、十三节）" id="{58c26ac4-297e-3027-4172-a36c27a59551}">
           <p14:sldIdLst>
             <p14:sldId id="285"/>
             <p14:sldId id="286"/>
@@ -196,7 +196,7 @@
             <p14:sldId id="288"/>
           </p14:sldIdLst>
         </p14:section>
-        <p14:section name="结语" id="{49ffd5ff-578e-1ad4-990a-0d7072b6aa56}">
+        <p14:section name="结语" id="{b022aa91-7993-ce99-8b26-22a0772f102d}">
           <p14:sldIdLst>
             <p14:sldId id="289"/>
             <p14:sldId id="290"/>
@@ -12260,7 +12260,7 @@
                 <a:ea typeface="Microsoft YaHei" pitchFamily="34" charset="-122"/>
                 <a:cs typeface="Microsoft YaHei" pitchFamily="34" charset="-120"/>
               </a:rPr>
-              <a:t>空格：播放或暂停；← →：上一节、下一节；拖动旋转，滚轮缩放，右键平移。点右上角「自动镜头」回到剧情视角。</a:t>
+              <a:t>空格：播放或暂停；← →：上一节、下一节；拖动平移，右键或 Ctrl 拖动旋转，滚轮缩放。点右上角「自动镜头」回到剧情视角。</a:t>
             </a:r>
             <a:endParaRPr lang="zh-CN" sz="1500" dirty="0"/>
           </a:p>

</xml_diff>

<commit_message>
Add turn and flip buttons beside the compass
Two round buttons turn the table 45 degrees counter-clockwise or
clockwise and a "翻转" button turns the view 180 degrees about its
centre to look from the opposite side; Q, E and R do the same from the
keyboard. Quick repeated clicks add up. Help text, README and the guide
deck mention the new buttons.

Co-Authored-By: Claude Opus 5.5 <noreply@anthropic.com>
Claude-Session: https://claude.ai/code/session_015Zqxwg6mTMYtB1fNrmJkji
</commit_message>
<xml_diff>
--- a/docs/feishui-guide.pptx
+++ b/docs/feishui-guide.pptx
@@ -143,7 +143,7 @@
   <p:extLst>
     <p:ext uri="{521415D9-36F7-43E2-AB2F-B90AF26B5E84}">
       <p14:sectionLst xmlns:p14="http://schemas.microsoft.com/office/powerpoint/2010/main">
-        <p14:section name="开篇" id="{a199276b-3eb3-79cc-e20d-23ae38b2c2fc}">
+        <p14:section name="开篇" id="{0186d107-b590-b2b4-6c83-7b74b2d33e77}">
           <p14:sldIdLst>
             <p14:sldId id="256"/>
             <p14:sldId id="257"/>
@@ -154,7 +154,7 @@
             <p14:sldId id="262"/>
           </p14:sldIdLst>
         </p14:section>
-        <p14:section name="战略全局（第一至三节）" id="{b40934d4-d029-dca2-543e-220a37492e2a}">
+        <p14:section name="战略全局（第一至三节）" id="{39d35c00-c5eb-d84b-d37a-6a51a57bc4f3}">
           <p14:sldIdLst>
             <p14:sldId id="263"/>
             <p14:sldId id="264"/>
@@ -164,7 +164,7 @@
             <p14:sldId id="268"/>
           </p14:sldIdLst>
         </p14:section>
-        <p14:section name="淝水战场（第四至八节）" id="{2f9758fc-9ecb-bb9a-9f82-57398edd4668}">
+        <p14:section name="淝水战场（第四至八节）" id="{cca17f03-514a-7b5c-8c61-14ce6d8de023}">
           <p14:sldIdLst>
             <p14:sldId id="269"/>
             <p14:sldId id="270"/>
@@ -178,7 +178,7 @@
             <p14:sldId id="278"/>
           </p14:sldIdLst>
         </p14:section>
-        <p14:section name="决战与溃败（第九至十一节）" id="{5152f7e5-281a-2d98-d79c-8ce06e07f44c}">
+        <p14:section name="决战与溃败（第九至十一节）" id="{3d021651-3c9d-a766-4ee8-24e3608f0f4f}">
           <p14:sldIdLst>
             <p14:sldId id="279"/>
             <p14:sldId id="280"/>
@@ -188,7 +188,7 @@
             <p14:sldId id="284"/>
           </p14:sldIdLst>
         </p14:section>
-        <p14:section name="战后（第十二、十三节）" id="{58c26ac4-297e-3027-4172-a36c27a59551}">
+        <p14:section name="战后（第十二、十三节）" id="{528aec03-472c-1d9f-f66e-eab6d562ac8f}">
           <p14:sldIdLst>
             <p14:sldId id="285"/>
             <p14:sldId id="286"/>
@@ -196,7 +196,7 @@
             <p14:sldId id="288"/>
           </p14:sldIdLst>
         </p14:section>
-        <p14:section name="结语" id="{b022aa91-7993-ce99-8b26-22a0772f102d}">
+        <p14:section name="结语" id="{9f3a92ef-e375-b8be-e177-8148b4d17041}">
           <p14:sldIdLst>
             <p14:sldId id="289"/>
             <p14:sldId id="290"/>
@@ -11834,11 +11834,11 @@
         <p:spPr>
           <a:xfrm>
             <a:off x="812902" y="1737360"/>
-            <a:ext cx="3339084" cy="3154680"/>
+            <a:ext cx="3339084" cy="3474720"/>
           </a:xfrm>
           <a:prstGeom prst="roundRect">
             <a:avLst>
-              <a:gd name="adj" fmla="val 2319"/>
+              <a:gd name="adj" fmla="val 2191"/>
             </a:avLst>
           </a:prstGeom>
           <a:solidFill>
@@ -11939,7 +11939,7 @@
         <p:spPr>
           <a:xfrm>
             <a:off x="1087222" y="3108960"/>
-            <a:ext cx="2790444" cy="2286000"/>
+            <a:ext cx="2790444" cy="2011680"/>
           </a:xfrm>
           <a:prstGeom prst="rect">
             <a:avLst/>
@@ -11981,11 +11981,11 @@
         <p:spPr>
           <a:xfrm>
             <a:off x="4426306" y="1737360"/>
-            <a:ext cx="3339084" cy="3154680"/>
+            <a:ext cx="3339084" cy="3474720"/>
           </a:xfrm>
           <a:prstGeom prst="roundRect">
             <a:avLst>
-              <a:gd name="adj" fmla="val 2319"/>
+              <a:gd name="adj" fmla="val 2191"/>
             </a:avLst>
           </a:prstGeom>
           <a:solidFill>
@@ -12086,7 +12086,7 @@
         <p:spPr>
           <a:xfrm>
             <a:off x="4700626" y="3108960"/>
-            <a:ext cx="2790444" cy="2286000"/>
+            <a:ext cx="2790444" cy="2011680"/>
           </a:xfrm>
           <a:prstGeom prst="rect">
             <a:avLst/>
@@ -12128,11 +12128,11 @@
         <p:spPr>
           <a:xfrm>
             <a:off x="8039710" y="1737360"/>
-            <a:ext cx="3339084" cy="3154680"/>
+            <a:ext cx="3339084" cy="3474720"/>
           </a:xfrm>
           <a:prstGeom prst="roundRect">
             <a:avLst>
-              <a:gd name="adj" fmla="val 2319"/>
+              <a:gd name="adj" fmla="val 2191"/>
             </a:avLst>
           </a:prstGeom>
           <a:solidFill>
@@ -12233,7 +12233,7 @@
         <p:spPr>
           <a:xfrm>
             <a:off x="8314030" y="3108960"/>
-            <a:ext cx="2790444" cy="2286000"/>
+            <a:ext cx="2790444" cy="2011680"/>
           </a:xfrm>
           <a:prstGeom prst="rect">
             <a:avLst/>
@@ -12260,7 +12260,7 @@
                 <a:ea typeface="Microsoft YaHei" pitchFamily="34" charset="-122"/>
                 <a:cs typeface="Microsoft YaHei" pitchFamily="34" charset="-120"/>
               </a:rPr>
-              <a:t>空格：播放或暂停；← →：上一节、下一节；拖动平移，右键或 Ctrl 拖动旋转，滚轮缩放。点右上角「自动镜头」回到剧情视角。</a:t>
+              <a:t>空格：播放或暂停；← →：上一节、下一节；拖动平移，右键或 Ctrl 拖动旋转，滚轮缩放；指北针旁的按钮可转向、翻转。点右上角「自动镜头」回到剧情视角。</a:t>
             </a:r>
             <a:endParaRPr lang="zh-CN" sz="1500" dirty="0"/>
           </a:p>

</xml_diff>